<commit_message>
Change bag on steroids to show half yellow/half blue balls
</commit_message>
<xml_diff>
--- a/lectures/from_propositional_logic_to_probability_theory/proportional_syllogism_on_steroids.pptx
+++ b/lectures/from_propositional_logic_to_probability_theory/proportional_syllogism_on_steroids.pptx
@@ -5,11 +5,12 @@
     <p:sldMasterId id="2147483684" r:id="rId1"/>
   </p:sldMasterIdLst>
   <p:notesMasterIdLst>
-    <p:notesMasterId r:id="rId4"/>
+    <p:notesMasterId r:id="rId5"/>
   </p:notesMasterIdLst>
   <p:sldIdLst>
     <p:sldId id="341" r:id="rId2"/>
-    <p:sldId id="342" r:id="rId3"/>
+    <p:sldId id="343" r:id="rId3"/>
+    <p:sldId id="342" r:id="rId4"/>
   </p:sldIdLst>
   <p:sldSz cx="9144000" cy="914400"/>
   <p:notesSz cx="6858000" cy="9144000"/>
@@ -3921,6 +3922,1128 @@
 </file>
 
 <file path=ppt/slides/slide2.xml><?xml version="1.0" encoding="utf-8"?>
+<p:sld xmlns:a="http://schemas.openxmlformats.org/drawingml/2006/main" xmlns:r="http://schemas.openxmlformats.org/officeDocument/2006/relationships" xmlns:p="http://schemas.openxmlformats.org/presentationml/2006/main">
+  <p:cSld>
+    <p:spTree>
+      <p:nvGrpSpPr>
+        <p:cNvPr id="1" name="">
+          <a:extLst>
+            <a:ext uri="{FF2B5EF4-FFF2-40B4-BE49-F238E27FC236}">
+              <a16:creationId xmlns:a16="http://schemas.microsoft.com/office/drawing/2014/main" id="{3676BE51-1AEE-8756-75D0-C2C2AAE6A2D2}"/>
+            </a:ext>
+          </a:extLst>
+        </p:cNvPr>
+        <p:cNvGrpSpPr/>
+        <p:nvPr/>
+      </p:nvGrpSpPr>
+      <p:grpSpPr>
+        <a:xfrm>
+          <a:off x="0" y="0"/>
+          <a:ext cx="0" cy="0"/>
+          <a:chOff x="0" y="0"/>
+          <a:chExt cx="0" cy="0"/>
+        </a:xfrm>
+      </p:grpSpPr>
+      <p:sp>
+        <p:nvSpPr>
+          <p:cNvPr id="26" name="Oval 25">
+            <a:extLst>
+              <a:ext uri="{FF2B5EF4-FFF2-40B4-BE49-F238E27FC236}">
+                <a16:creationId xmlns:a16="http://schemas.microsoft.com/office/drawing/2014/main" id="{D99E1143-0CD8-4697-C5F5-DC82255600C4}"/>
+              </a:ext>
+            </a:extLst>
+          </p:cNvPr>
+          <p:cNvSpPr>
+            <a:spLocks noChangeAspect="1"/>
+          </p:cNvSpPr>
+          <p:nvPr/>
+        </p:nvSpPr>
+        <p:spPr>
+          <a:xfrm>
+            <a:off x="3398889" y="234616"/>
+            <a:ext cx="457200" cy="457200"/>
+          </a:xfrm>
+          <a:prstGeom prst="ellipse">
+            <a:avLst/>
+          </a:prstGeom>
+          <a:solidFill>
+            <a:schemeClr val="accent1"/>
+          </a:solidFill>
+          <a:ln>
+            <a:solidFill>
+              <a:schemeClr val="bg1"/>
+            </a:solidFill>
+          </a:ln>
+        </p:spPr>
+        <p:style>
+          <a:lnRef idx="2">
+            <a:schemeClr val="accent1">
+              <a:shade val="15000"/>
+            </a:schemeClr>
+          </a:lnRef>
+          <a:fillRef idx="1">
+            <a:schemeClr val="accent1"/>
+          </a:fillRef>
+          <a:effectRef idx="0">
+            <a:schemeClr val="accent1"/>
+          </a:effectRef>
+          <a:fontRef idx="minor">
+            <a:schemeClr val="lt1"/>
+          </a:fontRef>
+        </p:style>
+        <p:txBody>
+          <a:bodyPr rtlCol="0" anchor="ctr"/>
+          <a:lstStyle/>
+          <a:p>
+            <a:pPr algn="ctr"/>
+            <a:endParaRPr lang="en-US"/>
+          </a:p>
+        </p:txBody>
+      </p:sp>
+      <p:sp>
+        <p:nvSpPr>
+          <p:cNvPr id="27" name="Oval 26">
+            <a:extLst>
+              <a:ext uri="{FF2B5EF4-FFF2-40B4-BE49-F238E27FC236}">
+                <a16:creationId xmlns:a16="http://schemas.microsoft.com/office/drawing/2014/main" id="{D693120E-51C3-A3E8-F892-C3F09D133238}"/>
+              </a:ext>
+            </a:extLst>
+          </p:cNvPr>
+          <p:cNvSpPr>
+            <a:spLocks noChangeAspect="1"/>
+          </p:cNvSpPr>
+          <p:nvPr/>
+        </p:nvSpPr>
+        <p:spPr>
+          <a:xfrm>
+            <a:off x="2770585" y="228186"/>
+            <a:ext cx="457200" cy="457200"/>
+          </a:xfrm>
+          <a:prstGeom prst="ellipse">
+            <a:avLst/>
+          </a:prstGeom>
+          <a:solidFill>
+            <a:schemeClr val="accent4"/>
+          </a:solidFill>
+          <a:ln>
+            <a:solidFill>
+              <a:schemeClr val="bg1"/>
+            </a:solidFill>
+          </a:ln>
+        </p:spPr>
+        <p:style>
+          <a:lnRef idx="2">
+            <a:schemeClr val="accent1">
+              <a:shade val="15000"/>
+            </a:schemeClr>
+          </a:lnRef>
+          <a:fillRef idx="1">
+            <a:schemeClr val="accent1"/>
+          </a:fillRef>
+          <a:effectRef idx="0">
+            <a:schemeClr val="accent1"/>
+          </a:effectRef>
+          <a:fontRef idx="minor">
+            <a:schemeClr val="lt1"/>
+          </a:fontRef>
+        </p:style>
+        <p:txBody>
+          <a:bodyPr rtlCol="0" anchor="ctr"/>
+          <a:lstStyle/>
+          <a:p>
+            <a:pPr algn="ctr"/>
+            <a:endParaRPr lang="en-US"/>
+          </a:p>
+        </p:txBody>
+      </p:sp>
+      <p:sp>
+        <p:nvSpPr>
+          <p:cNvPr id="2" name="Oval 1">
+            <a:extLst>
+              <a:ext uri="{FF2B5EF4-FFF2-40B4-BE49-F238E27FC236}">
+                <a16:creationId xmlns:a16="http://schemas.microsoft.com/office/drawing/2014/main" id="{737A75BE-2D36-D20C-63E6-32D2960BFA64}"/>
+              </a:ext>
+            </a:extLst>
+          </p:cNvPr>
+          <p:cNvSpPr>
+            <a:spLocks noChangeAspect="1"/>
+          </p:cNvSpPr>
+          <p:nvPr/>
+        </p:nvSpPr>
+        <p:spPr>
+          <a:xfrm>
+            <a:off x="1497541" y="228600"/>
+            <a:ext cx="457200" cy="457200"/>
+          </a:xfrm>
+          <a:prstGeom prst="ellipse">
+            <a:avLst/>
+          </a:prstGeom>
+          <a:solidFill>
+            <a:schemeClr val="accent4"/>
+          </a:solidFill>
+          <a:ln>
+            <a:solidFill>
+              <a:schemeClr val="bg1"/>
+            </a:solidFill>
+          </a:ln>
+        </p:spPr>
+        <p:style>
+          <a:lnRef idx="2">
+            <a:schemeClr val="accent1">
+              <a:shade val="15000"/>
+            </a:schemeClr>
+          </a:lnRef>
+          <a:fillRef idx="1">
+            <a:schemeClr val="accent1"/>
+          </a:fillRef>
+          <a:effectRef idx="0">
+            <a:schemeClr val="accent1"/>
+          </a:effectRef>
+          <a:fontRef idx="minor">
+            <a:schemeClr val="lt1"/>
+          </a:fontRef>
+        </p:style>
+        <p:txBody>
+          <a:bodyPr rtlCol="0" anchor="ctr"/>
+          <a:lstStyle/>
+          <a:p>
+            <a:pPr algn="ctr"/>
+            <a:endParaRPr lang="en-US"/>
+          </a:p>
+        </p:txBody>
+      </p:sp>
+      <p:sp>
+        <p:nvSpPr>
+          <p:cNvPr id="3" name="Oval 2">
+            <a:extLst>
+              <a:ext uri="{FF2B5EF4-FFF2-40B4-BE49-F238E27FC236}">
+                <a16:creationId xmlns:a16="http://schemas.microsoft.com/office/drawing/2014/main" id="{F8838413-0BD9-BD7B-B9F0-DD0B776B60C1}"/>
+              </a:ext>
+            </a:extLst>
+          </p:cNvPr>
+          <p:cNvSpPr>
+            <a:spLocks noChangeAspect="1"/>
+          </p:cNvSpPr>
+          <p:nvPr/>
+        </p:nvSpPr>
+        <p:spPr>
+          <a:xfrm>
+            <a:off x="2129954" y="228600"/>
+            <a:ext cx="457200" cy="457200"/>
+          </a:xfrm>
+          <a:prstGeom prst="ellipse">
+            <a:avLst/>
+          </a:prstGeom>
+          <a:solidFill>
+            <a:schemeClr val="accent4"/>
+          </a:solidFill>
+          <a:ln>
+            <a:solidFill>
+              <a:schemeClr val="bg1"/>
+            </a:solidFill>
+          </a:ln>
+        </p:spPr>
+        <p:style>
+          <a:lnRef idx="2">
+            <a:schemeClr val="accent1">
+              <a:shade val="15000"/>
+            </a:schemeClr>
+          </a:lnRef>
+          <a:fillRef idx="1">
+            <a:schemeClr val="accent1"/>
+          </a:fillRef>
+          <a:effectRef idx="0">
+            <a:schemeClr val="accent1"/>
+          </a:effectRef>
+          <a:fontRef idx="minor">
+            <a:schemeClr val="lt1"/>
+          </a:fontRef>
+        </p:style>
+        <p:txBody>
+          <a:bodyPr rtlCol="0" anchor="ctr"/>
+          <a:lstStyle/>
+          <a:p>
+            <a:pPr algn="ctr"/>
+            <a:endParaRPr lang="en-US"/>
+          </a:p>
+        </p:txBody>
+      </p:sp>
+      <p:sp>
+        <p:nvSpPr>
+          <p:cNvPr id="6" name="Oval 5">
+            <a:extLst>
+              <a:ext uri="{FF2B5EF4-FFF2-40B4-BE49-F238E27FC236}">
+                <a16:creationId xmlns:a16="http://schemas.microsoft.com/office/drawing/2014/main" id="{3CB09799-CBA5-7E88-0752-369CE44DB8D1}"/>
+              </a:ext>
+            </a:extLst>
+          </p:cNvPr>
+          <p:cNvSpPr>
+            <a:spLocks noChangeAspect="1"/>
+          </p:cNvSpPr>
+          <p:nvPr/>
+        </p:nvSpPr>
+        <p:spPr>
+          <a:xfrm>
+            <a:off x="4027193" y="228600"/>
+            <a:ext cx="457200" cy="457200"/>
+          </a:xfrm>
+          <a:prstGeom prst="ellipse">
+            <a:avLst/>
+          </a:prstGeom>
+          <a:solidFill>
+            <a:schemeClr val="accent1"/>
+          </a:solidFill>
+          <a:ln>
+            <a:solidFill>
+              <a:schemeClr val="bg1"/>
+            </a:solidFill>
+          </a:ln>
+        </p:spPr>
+        <p:style>
+          <a:lnRef idx="2">
+            <a:schemeClr val="accent1">
+              <a:shade val="15000"/>
+            </a:schemeClr>
+          </a:lnRef>
+          <a:fillRef idx="1">
+            <a:schemeClr val="accent1"/>
+          </a:fillRef>
+          <a:effectRef idx="0">
+            <a:schemeClr val="accent1"/>
+          </a:effectRef>
+          <a:fontRef idx="minor">
+            <a:schemeClr val="lt1"/>
+          </a:fontRef>
+        </p:style>
+        <p:txBody>
+          <a:bodyPr rtlCol="0" anchor="ctr"/>
+          <a:lstStyle/>
+          <a:p>
+            <a:pPr algn="ctr"/>
+            <a:endParaRPr lang="en-US"/>
+          </a:p>
+        </p:txBody>
+      </p:sp>
+      <p:sp>
+        <p:nvSpPr>
+          <p:cNvPr id="7" name="Oval 6">
+            <a:extLst>
+              <a:ext uri="{FF2B5EF4-FFF2-40B4-BE49-F238E27FC236}">
+                <a16:creationId xmlns:a16="http://schemas.microsoft.com/office/drawing/2014/main" id="{4898D57F-2B18-C226-3B6A-092C2966978B}"/>
+              </a:ext>
+            </a:extLst>
+          </p:cNvPr>
+          <p:cNvSpPr>
+            <a:spLocks noChangeAspect="1"/>
+          </p:cNvSpPr>
+          <p:nvPr/>
+        </p:nvSpPr>
+        <p:spPr>
+          <a:xfrm>
+            <a:off x="4659606" y="228600"/>
+            <a:ext cx="457200" cy="457200"/>
+          </a:xfrm>
+          <a:prstGeom prst="ellipse">
+            <a:avLst/>
+          </a:prstGeom>
+          <a:solidFill>
+            <a:schemeClr val="accent1"/>
+          </a:solidFill>
+          <a:ln>
+            <a:solidFill>
+              <a:schemeClr val="bg1"/>
+            </a:solidFill>
+          </a:ln>
+        </p:spPr>
+        <p:style>
+          <a:lnRef idx="2">
+            <a:schemeClr val="accent1">
+              <a:shade val="15000"/>
+            </a:schemeClr>
+          </a:lnRef>
+          <a:fillRef idx="1">
+            <a:schemeClr val="accent1"/>
+          </a:fillRef>
+          <a:effectRef idx="0">
+            <a:schemeClr val="accent1"/>
+          </a:effectRef>
+          <a:fontRef idx="minor">
+            <a:schemeClr val="lt1"/>
+          </a:fontRef>
+        </p:style>
+        <p:txBody>
+          <a:bodyPr rtlCol="0" anchor="ctr"/>
+          <a:lstStyle/>
+          <a:p>
+            <a:pPr algn="ctr"/>
+            <a:endParaRPr lang="en-US"/>
+          </a:p>
+        </p:txBody>
+      </p:sp>
+      <p:sp>
+        <p:nvSpPr>
+          <p:cNvPr id="8" name="Oval 7">
+            <a:extLst>
+              <a:ext uri="{FF2B5EF4-FFF2-40B4-BE49-F238E27FC236}">
+                <a16:creationId xmlns:a16="http://schemas.microsoft.com/office/drawing/2014/main" id="{D74C488C-2B7F-0AB6-3BFC-F1D5B987974C}"/>
+              </a:ext>
+            </a:extLst>
+          </p:cNvPr>
+          <p:cNvSpPr>
+            <a:spLocks noChangeAspect="1"/>
+          </p:cNvSpPr>
+          <p:nvPr/>
+        </p:nvSpPr>
+        <p:spPr>
+          <a:xfrm>
+            <a:off x="5292019" y="228600"/>
+            <a:ext cx="457200" cy="457200"/>
+          </a:xfrm>
+          <a:prstGeom prst="ellipse">
+            <a:avLst/>
+          </a:prstGeom>
+          <a:solidFill>
+            <a:schemeClr val="accent1"/>
+          </a:solidFill>
+          <a:ln>
+            <a:solidFill>
+              <a:schemeClr val="bg1"/>
+            </a:solidFill>
+          </a:ln>
+        </p:spPr>
+        <p:style>
+          <a:lnRef idx="2">
+            <a:schemeClr val="accent1">
+              <a:shade val="15000"/>
+            </a:schemeClr>
+          </a:lnRef>
+          <a:fillRef idx="1">
+            <a:schemeClr val="accent1"/>
+          </a:fillRef>
+          <a:effectRef idx="0">
+            <a:schemeClr val="accent1"/>
+          </a:effectRef>
+          <a:fontRef idx="minor">
+            <a:schemeClr val="lt1"/>
+          </a:fontRef>
+        </p:style>
+        <p:txBody>
+          <a:bodyPr rtlCol="0" anchor="ctr"/>
+          <a:lstStyle/>
+          <a:p>
+            <a:pPr algn="ctr"/>
+            <a:endParaRPr lang="en-US"/>
+          </a:p>
+        </p:txBody>
+      </p:sp>
+      <p:sp>
+        <p:nvSpPr>
+          <p:cNvPr id="9" name="Oval 8">
+            <a:extLst>
+              <a:ext uri="{FF2B5EF4-FFF2-40B4-BE49-F238E27FC236}">
+                <a16:creationId xmlns:a16="http://schemas.microsoft.com/office/drawing/2014/main" id="{EB38A921-2924-066A-BC93-323477DC4E74}"/>
+              </a:ext>
+            </a:extLst>
+          </p:cNvPr>
+          <p:cNvSpPr>
+            <a:spLocks noChangeAspect="1"/>
+          </p:cNvSpPr>
+          <p:nvPr/>
+        </p:nvSpPr>
+        <p:spPr>
+          <a:xfrm>
+            <a:off x="5924432" y="228600"/>
+            <a:ext cx="457200" cy="457200"/>
+          </a:xfrm>
+          <a:prstGeom prst="ellipse">
+            <a:avLst/>
+          </a:prstGeom>
+          <a:solidFill>
+            <a:srgbClr val="8EBB6F"/>
+          </a:solidFill>
+          <a:ln>
+            <a:solidFill>
+              <a:schemeClr val="bg1"/>
+            </a:solidFill>
+          </a:ln>
+        </p:spPr>
+        <p:style>
+          <a:lnRef idx="2">
+            <a:schemeClr val="accent1">
+              <a:shade val="15000"/>
+            </a:schemeClr>
+          </a:lnRef>
+          <a:fillRef idx="1">
+            <a:schemeClr val="accent1"/>
+          </a:fillRef>
+          <a:effectRef idx="0">
+            <a:schemeClr val="accent1"/>
+          </a:effectRef>
+          <a:fontRef idx="minor">
+            <a:schemeClr val="lt1"/>
+          </a:fontRef>
+        </p:style>
+        <p:txBody>
+          <a:bodyPr rtlCol="0" anchor="ctr"/>
+          <a:lstStyle/>
+          <a:p>
+            <a:pPr algn="ctr"/>
+            <a:endParaRPr lang="en-US"/>
+          </a:p>
+        </p:txBody>
+      </p:sp>
+      <p:sp>
+        <p:nvSpPr>
+          <p:cNvPr id="10" name="Oval 9">
+            <a:extLst>
+              <a:ext uri="{FF2B5EF4-FFF2-40B4-BE49-F238E27FC236}">
+                <a16:creationId xmlns:a16="http://schemas.microsoft.com/office/drawing/2014/main" id="{2A3F9291-88B7-3857-CF8F-BD9E1811E422}"/>
+              </a:ext>
+            </a:extLst>
+          </p:cNvPr>
+          <p:cNvSpPr>
+            <a:spLocks noChangeAspect="1"/>
+          </p:cNvSpPr>
+          <p:nvPr/>
+        </p:nvSpPr>
+        <p:spPr>
+          <a:xfrm>
+            <a:off x="6556845" y="228600"/>
+            <a:ext cx="457200" cy="457200"/>
+          </a:xfrm>
+          <a:prstGeom prst="ellipse">
+            <a:avLst/>
+          </a:prstGeom>
+          <a:solidFill>
+            <a:srgbClr val="8EBB6F"/>
+          </a:solidFill>
+          <a:ln>
+            <a:solidFill>
+              <a:schemeClr val="bg1"/>
+            </a:solidFill>
+          </a:ln>
+        </p:spPr>
+        <p:style>
+          <a:lnRef idx="2">
+            <a:schemeClr val="accent1">
+              <a:shade val="15000"/>
+            </a:schemeClr>
+          </a:lnRef>
+          <a:fillRef idx="1">
+            <a:schemeClr val="accent1"/>
+          </a:fillRef>
+          <a:effectRef idx="0">
+            <a:schemeClr val="accent1"/>
+          </a:effectRef>
+          <a:fontRef idx="minor">
+            <a:schemeClr val="lt1"/>
+          </a:fontRef>
+        </p:style>
+        <p:txBody>
+          <a:bodyPr rtlCol="0" anchor="ctr"/>
+          <a:lstStyle/>
+          <a:p>
+            <a:pPr algn="ctr"/>
+            <a:endParaRPr lang="en-US"/>
+          </a:p>
+        </p:txBody>
+      </p:sp>
+      <p:sp>
+        <p:nvSpPr>
+          <p:cNvPr id="11" name="Oval 10">
+            <a:extLst>
+              <a:ext uri="{FF2B5EF4-FFF2-40B4-BE49-F238E27FC236}">
+                <a16:creationId xmlns:a16="http://schemas.microsoft.com/office/drawing/2014/main" id="{B05A744D-12B5-8687-4C4E-DEA7C966218B}"/>
+              </a:ext>
+            </a:extLst>
+          </p:cNvPr>
+          <p:cNvSpPr>
+            <a:spLocks noChangeAspect="1"/>
+          </p:cNvSpPr>
+          <p:nvPr/>
+        </p:nvSpPr>
+        <p:spPr>
+          <a:xfrm>
+            <a:off x="7189259" y="228600"/>
+            <a:ext cx="457200" cy="457200"/>
+          </a:xfrm>
+          <a:prstGeom prst="ellipse">
+            <a:avLst/>
+          </a:prstGeom>
+          <a:noFill/>
+          <a:ln>
+            <a:solidFill>
+              <a:schemeClr val="bg2">
+                <a:lumMod val="90000"/>
+              </a:schemeClr>
+            </a:solidFill>
+          </a:ln>
+        </p:spPr>
+        <p:style>
+          <a:lnRef idx="2">
+            <a:schemeClr val="accent1">
+              <a:shade val="15000"/>
+            </a:schemeClr>
+          </a:lnRef>
+          <a:fillRef idx="1">
+            <a:schemeClr val="accent1"/>
+          </a:fillRef>
+          <a:effectRef idx="0">
+            <a:schemeClr val="accent1"/>
+          </a:effectRef>
+          <a:fontRef idx="minor">
+            <a:schemeClr val="lt1"/>
+          </a:fontRef>
+        </p:style>
+        <p:txBody>
+          <a:bodyPr rtlCol="0" anchor="ctr"/>
+          <a:lstStyle/>
+          <a:p>
+            <a:pPr algn="ctr"/>
+            <a:endParaRPr lang="en-US"/>
+          </a:p>
+        </p:txBody>
+      </p:sp>
+      <p:grpSp>
+        <p:nvGrpSpPr>
+          <p:cNvPr id="20" name="Group 19">
+            <a:extLst>
+              <a:ext uri="{FF2B5EF4-FFF2-40B4-BE49-F238E27FC236}">
+                <a16:creationId xmlns:a16="http://schemas.microsoft.com/office/drawing/2014/main" id="{1562CAD8-24B8-FA0F-C49A-5A02CBCA6435}"/>
+              </a:ext>
+            </a:extLst>
+          </p:cNvPr>
+          <p:cNvGrpSpPr/>
+          <p:nvPr/>
+        </p:nvGrpSpPr>
+        <p:grpSpPr>
+          <a:xfrm>
+            <a:off x="5924432" y="228600"/>
+            <a:ext cx="457200" cy="457200"/>
+            <a:chOff x="3394780" y="228600"/>
+            <a:chExt cx="457200" cy="457200"/>
+          </a:xfrm>
+        </p:grpSpPr>
+        <p:sp>
+          <p:nvSpPr>
+            <p:cNvPr id="21" name="Freeform 20">
+              <a:extLst>
+                <a:ext uri="{FF2B5EF4-FFF2-40B4-BE49-F238E27FC236}">
+                  <a16:creationId xmlns:a16="http://schemas.microsoft.com/office/drawing/2014/main" id="{D466B029-7C52-3DD1-2A86-23C25ECFE792}"/>
+                </a:ext>
+              </a:extLst>
+            </p:cNvPr>
+            <p:cNvSpPr>
+              <a:spLocks noChangeAspect="1"/>
+            </p:cNvSpPr>
+            <p:nvPr/>
+          </p:nvSpPr>
+          <p:spPr>
+            <a:xfrm>
+              <a:off x="3394780" y="229014"/>
+              <a:ext cx="224492" cy="456372"/>
+            </a:xfrm>
+            <a:custGeom>
+              <a:avLst/>
+              <a:gdLst>
+                <a:gd name="connsiteX0" fmla="*/ 224492 w 224492"/>
+                <a:gd name="connsiteY0" fmla="*/ 0 h 456372"/>
+                <a:gd name="connsiteX1" fmla="*/ 224492 w 224492"/>
+                <a:gd name="connsiteY1" fmla="*/ 456372 h 456372"/>
+                <a:gd name="connsiteX2" fmla="*/ 182529 w 224492"/>
+                <a:gd name="connsiteY2" fmla="*/ 452142 h 456372"/>
+                <a:gd name="connsiteX3" fmla="*/ 0 w 224492"/>
+                <a:gd name="connsiteY3" fmla="*/ 228186 h 456372"/>
+                <a:gd name="connsiteX4" fmla="*/ 182529 w 224492"/>
+                <a:gd name="connsiteY4" fmla="*/ 4230 h 456372"/>
+                <a:gd name="connsiteX5" fmla="*/ 224492 w 224492"/>
+                <a:gd name="connsiteY5" fmla="*/ 0 h 456372"/>
+              </a:gdLst>
+              <a:ahLst/>
+              <a:cxnLst>
+                <a:cxn ang="0">
+                  <a:pos x="connsiteX0" y="connsiteY0"/>
+                </a:cxn>
+                <a:cxn ang="0">
+                  <a:pos x="connsiteX1" y="connsiteY1"/>
+                </a:cxn>
+                <a:cxn ang="0">
+                  <a:pos x="connsiteX2" y="connsiteY2"/>
+                </a:cxn>
+                <a:cxn ang="0">
+                  <a:pos x="connsiteX3" y="connsiteY3"/>
+                </a:cxn>
+                <a:cxn ang="0">
+                  <a:pos x="connsiteX4" y="connsiteY4"/>
+                </a:cxn>
+                <a:cxn ang="0">
+                  <a:pos x="connsiteX5" y="connsiteY5"/>
+                </a:cxn>
+              </a:cxnLst>
+              <a:rect l="l" t="t" r="r" b="b"/>
+              <a:pathLst>
+                <a:path w="224492" h="456372">
+                  <a:moveTo>
+                    <a:pt x="224492" y="0"/>
+                  </a:moveTo>
+                  <a:lnTo>
+                    <a:pt x="224492" y="456372"/>
+                  </a:lnTo>
+                  <a:lnTo>
+                    <a:pt x="182529" y="452142"/>
+                  </a:lnTo>
+                  <a:cubicBezTo>
+                    <a:pt x="78360" y="430826"/>
+                    <a:pt x="0" y="338657"/>
+                    <a:pt x="0" y="228186"/>
+                  </a:cubicBezTo>
+                  <a:cubicBezTo>
+                    <a:pt x="0" y="117716"/>
+                    <a:pt x="78360" y="25547"/>
+                    <a:pt x="182529" y="4230"/>
+                  </a:cubicBezTo>
+                  <a:lnTo>
+                    <a:pt x="224492" y="0"/>
+                  </a:lnTo>
+                  <a:close/>
+                </a:path>
+              </a:pathLst>
+            </a:custGeom>
+            <a:solidFill>
+              <a:schemeClr val="accent4"/>
+            </a:solidFill>
+            <a:ln>
+              <a:solidFill>
+                <a:schemeClr val="bg1"/>
+              </a:solidFill>
+            </a:ln>
+          </p:spPr>
+          <p:style>
+            <a:lnRef idx="2">
+              <a:schemeClr val="accent1">
+                <a:shade val="15000"/>
+              </a:schemeClr>
+            </a:lnRef>
+            <a:fillRef idx="1">
+              <a:schemeClr val="accent1"/>
+            </a:fillRef>
+            <a:effectRef idx="0">
+              <a:schemeClr val="accent1"/>
+            </a:effectRef>
+            <a:fontRef idx="minor">
+              <a:schemeClr val="lt1"/>
+            </a:fontRef>
+          </p:style>
+          <p:txBody>
+            <a:bodyPr wrap="square" rtlCol="0" anchor="ctr">
+              <a:noAutofit/>
+            </a:bodyPr>
+            <a:lstStyle/>
+            <a:p>
+              <a:pPr algn="ctr"/>
+              <a:endParaRPr lang="en-US" dirty="0"/>
+            </a:p>
+          </p:txBody>
+        </p:sp>
+        <p:sp>
+          <p:nvSpPr>
+            <p:cNvPr id="22" name="Freeform 21">
+              <a:extLst>
+                <a:ext uri="{FF2B5EF4-FFF2-40B4-BE49-F238E27FC236}">
+                  <a16:creationId xmlns:a16="http://schemas.microsoft.com/office/drawing/2014/main" id="{69A8A1A2-E09D-7F52-053B-B2606CFEF96A}"/>
+                </a:ext>
+              </a:extLst>
+            </p:cNvPr>
+            <p:cNvSpPr>
+              <a:spLocks noChangeAspect="1"/>
+            </p:cNvSpPr>
+            <p:nvPr/>
+          </p:nvSpPr>
+          <p:spPr>
+            <a:xfrm>
+              <a:off x="3619272" y="228600"/>
+              <a:ext cx="232708" cy="457200"/>
+            </a:xfrm>
+            <a:custGeom>
+              <a:avLst/>
+              <a:gdLst>
+                <a:gd name="connsiteX0" fmla="*/ 4108 w 232708"/>
+                <a:gd name="connsiteY0" fmla="*/ 0 h 457200"/>
+                <a:gd name="connsiteX1" fmla="*/ 232708 w 232708"/>
+                <a:gd name="connsiteY1" fmla="*/ 228600 h 457200"/>
+                <a:gd name="connsiteX2" fmla="*/ 4108 w 232708"/>
+                <a:gd name="connsiteY2" fmla="*/ 457200 h 457200"/>
+                <a:gd name="connsiteX3" fmla="*/ 0 w 232708"/>
+                <a:gd name="connsiteY3" fmla="*/ 456786 h 457200"/>
+                <a:gd name="connsiteX4" fmla="*/ 0 w 232708"/>
+                <a:gd name="connsiteY4" fmla="*/ 414 h 457200"/>
+                <a:gd name="connsiteX5" fmla="*/ 4108 w 232708"/>
+                <a:gd name="connsiteY5" fmla="*/ 0 h 457200"/>
+              </a:gdLst>
+              <a:ahLst/>
+              <a:cxnLst>
+                <a:cxn ang="0">
+                  <a:pos x="connsiteX0" y="connsiteY0"/>
+                </a:cxn>
+                <a:cxn ang="0">
+                  <a:pos x="connsiteX1" y="connsiteY1"/>
+                </a:cxn>
+                <a:cxn ang="0">
+                  <a:pos x="connsiteX2" y="connsiteY2"/>
+                </a:cxn>
+                <a:cxn ang="0">
+                  <a:pos x="connsiteX3" y="connsiteY3"/>
+                </a:cxn>
+                <a:cxn ang="0">
+                  <a:pos x="connsiteX4" y="connsiteY4"/>
+                </a:cxn>
+                <a:cxn ang="0">
+                  <a:pos x="connsiteX5" y="connsiteY5"/>
+                </a:cxn>
+              </a:cxnLst>
+              <a:rect l="l" t="t" r="r" b="b"/>
+              <a:pathLst>
+                <a:path w="232708" h="457200">
+                  <a:moveTo>
+                    <a:pt x="4108" y="0"/>
+                  </a:moveTo>
+                  <a:cubicBezTo>
+                    <a:pt x="130360" y="0"/>
+                    <a:pt x="232708" y="102348"/>
+                    <a:pt x="232708" y="228600"/>
+                  </a:cubicBezTo>
+                  <a:cubicBezTo>
+                    <a:pt x="232708" y="354852"/>
+                    <a:pt x="130360" y="457200"/>
+                    <a:pt x="4108" y="457200"/>
+                  </a:cubicBezTo>
+                  <a:lnTo>
+                    <a:pt x="0" y="456786"/>
+                  </a:lnTo>
+                  <a:lnTo>
+                    <a:pt x="0" y="414"/>
+                  </a:lnTo>
+                  <a:lnTo>
+                    <a:pt x="4108" y="0"/>
+                  </a:lnTo>
+                  <a:close/>
+                </a:path>
+              </a:pathLst>
+            </a:custGeom>
+            <a:solidFill>
+              <a:schemeClr val="accent1"/>
+            </a:solidFill>
+            <a:ln>
+              <a:solidFill>
+                <a:schemeClr val="bg1"/>
+              </a:solidFill>
+            </a:ln>
+          </p:spPr>
+          <p:style>
+            <a:lnRef idx="2">
+              <a:schemeClr val="accent1">
+                <a:shade val="15000"/>
+              </a:schemeClr>
+            </a:lnRef>
+            <a:fillRef idx="1">
+              <a:schemeClr val="accent1"/>
+            </a:fillRef>
+            <a:effectRef idx="0">
+              <a:schemeClr val="accent1"/>
+            </a:effectRef>
+            <a:fontRef idx="minor">
+              <a:schemeClr val="lt1"/>
+            </a:fontRef>
+          </p:style>
+          <p:txBody>
+            <a:bodyPr wrap="square" rtlCol="0" anchor="ctr">
+              <a:noAutofit/>
+            </a:bodyPr>
+            <a:lstStyle/>
+            <a:p>
+              <a:pPr algn="ctr"/>
+              <a:endParaRPr lang="en-US" dirty="0"/>
+            </a:p>
+          </p:txBody>
+        </p:sp>
+      </p:grpSp>
+      <p:grpSp>
+        <p:nvGrpSpPr>
+          <p:cNvPr id="23" name="Group 22">
+            <a:extLst>
+              <a:ext uri="{FF2B5EF4-FFF2-40B4-BE49-F238E27FC236}">
+                <a16:creationId xmlns:a16="http://schemas.microsoft.com/office/drawing/2014/main" id="{E8BA12F4-524C-52A1-B119-533CDDBE00A5}"/>
+              </a:ext>
+            </a:extLst>
+          </p:cNvPr>
+          <p:cNvGrpSpPr/>
+          <p:nvPr/>
+        </p:nvGrpSpPr>
+        <p:grpSpPr>
+          <a:xfrm>
+            <a:off x="6556845" y="240506"/>
+            <a:ext cx="457200" cy="457200"/>
+            <a:chOff x="3394780" y="228600"/>
+            <a:chExt cx="457200" cy="457200"/>
+          </a:xfrm>
+        </p:grpSpPr>
+        <p:sp>
+          <p:nvSpPr>
+            <p:cNvPr id="24" name="Freeform 23">
+              <a:extLst>
+                <a:ext uri="{FF2B5EF4-FFF2-40B4-BE49-F238E27FC236}">
+                  <a16:creationId xmlns:a16="http://schemas.microsoft.com/office/drawing/2014/main" id="{1D8FAC97-8A60-85C9-2BDF-C4418FF1C1EF}"/>
+                </a:ext>
+              </a:extLst>
+            </p:cNvPr>
+            <p:cNvSpPr>
+              <a:spLocks noChangeAspect="1"/>
+            </p:cNvSpPr>
+            <p:nvPr/>
+          </p:nvSpPr>
+          <p:spPr>
+            <a:xfrm>
+              <a:off x="3394780" y="229014"/>
+              <a:ext cx="224492" cy="456372"/>
+            </a:xfrm>
+            <a:custGeom>
+              <a:avLst/>
+              <a:gdLst>
+                <a:gd name="connsiteX0" fmla="*/ 224492 w 224492"/>
+                <a:gd name="connsiteY0" fmla="*/ 0 h 456372"/>
+                <a:gd name="connsiteX1" fmla="*/ 224492 w 224492"/>
+                <a:gd name="connsiteY1" fmla="*/ 456372 h 456372"/>
+                <a:gd name="connsiteX2" fmla="*/ 182529 w 224492"/>
+                <a:gd name="connsiteY2" fmla="*/ 452142 h 456372"/>
+                <a:gd name="connsiteX3" fmla="*/ 0 w 224492"/>
+                <a:gd name="connsiteY3" fmla="*/ 228186 h 456372"/>
+                <a:gd name="connsiteX4" fmla="*/ 182529 w 224492"/>
+                <a:gd name="connsiteY4" fmla="*/ 4230 h 456372"/>
+                <a:gd name="connsiteX5" fmla="*/ 224492 w 224492"/>
+                <a:gd name="connsiteY5" fmla="*/ 0 h 456372"/>
+              </a:gdLst>
+              <a:ahLst/>
+              <a:cxnLst>
+                <a:cxn ang="0">
+                  <a:pos x="connsiteX0" y="connsiteY0"/>
+                </a:cxn>
+                <a:cxn ang="0">
+                  <a:pos x="connsiteX1" y="connsiteY1"/>
+                </a:cxn>
+                <a:cxn ang="0">
+                  <a:pos x="connsiteX2" y="connsiteY2"/>
+                </a:cxn>
+                <a:cxn ang="0">
+                  <a:pos x="connsiteX3" y="connsiteY3"/>
+                </a:cxn>
+                <a:cxn ang="0">
+                  <a:pos x="connsiteX4" y="connsiteY4"/>
+                </a:cxn>
+                <a:cxn ang="0">
+                  <a:pos x="connsiteX5" y="connsiteY5"/>
+                </a:cxn>
+              </a:cxnLst>
+              <a:rect l="l" t="t" r="r" b="b"/>
+              <a:pathLst>
+                <a:path w="224492" h="456372">
+                  <a:moveTo>
+                    <a:pt x="224492" y="0"/>
+                  </a:moveTo>
+                  <a:lnTo>
+                    <a:pt x="224492" y="456372"/>
+                  </a:lnTo>
+                  <a:lnTo>
+                    <a:pt x="182529" y="452142"/>
+                  </a:lnTo>
+                  <a:cubicBezTo>
+                    <a:pt x="78360" y="430826"/>
+                    <a:pt x="0" y="338657"/>
+                    <a:pt x="0" y="228186"/>
+                  </a:cubicBezTo>
+                  <a:cubicBezTo>
+                    <a:pt x="0" y="117716"/>
+                    <a:pt x="78360" y="25547"/>
+                    <a:pt x="182529" y="4230"/>
+                  </a:cubicBezTo>
+                  <a:lnTo>
+                    <a:pt x="224492" y="0"/>
+                  </a:lnTo>
+                  <a:close/>
+                </a:path>
+              </a:pathLst>
+            </a:custGeom>
+            <a:solidFill>
+              <a:schemeClr val="accent4"/>
+            </a:solidFill>
+            <a:ln>
+              <a:solidFill>
+                <a:schemeClr val="bg1"/>
+              </a:solidFill>
+            </a:ln>
+          </p:spPr>
+          <p:style>
+            <a:lnRef idx="2">
+              <a:schemeClr val="accent1">
+                <a:shade val="15000"/>
+              </a:schemeClr>
+            </a:lnRef>
+            <a:fillRef idx="1">
+              <a:schemeClr val="accent1"/>
+            </a:fillRef>
+            <a:effectRef idx="0">
+              <a:schemeClr val="accent1"/>
+            </a:effectRef>
+            <a:fontRef idx="minor">
+              <a:schemeClr val="lt1"/>
+            </a:fontRef>
+          </p:style>
+          <p:txBody>
+            <a:bodyPr wrap="square" rtlCol="0" anchor="ctr">
+              <a:noAutofit/>
+            </a:bodyPr>
+            <a:lstStyle/>
+            <a:p>
+              <a:pPr algn="ctr"/>
+              <a:endParaRPr lang="en-US" dirty="0"/>
+            </a:p>
+          </p:txBody>
+        </p:sp>
+        <p:sp>
+          <p:nvSpPr>
+            <p:cNvPr id="25" name="Freeform 24">
+              <a:extLst>
+                <a:ext uri="{FF2B5EF4-FFF2-40B4-BE49-F238E27FC236}">
+                  <a16:creationId xmlns:a16="http://schemas.microsoft.com/office/drawing/2014/main" id="{6F98C09D-CAF8-D8DF-076F-7D4B0B759279}"/>
+                </a:ext>
+              </a:extLst>
+            </p:cNvPr>
+            <p:cNvSpPr>
+              <a:spLocks noChangeAspect="1"/>
+            </p:cNvSpPr>
+            <p:nvPr/>
+          </p:nvSpPr>
+          <p:spPr>
+            <a:xfrm>
+              <a:off x="3619272" y="228600"/>
+              <a:ext cx="232708" cy="457200"/>
+            </a:xfrm>
+            <a:custGeom>
+              <a:avLst/>
+              <a:gdLst>
+                <a:gd name="connsiteX0" fmla="*/ 4108 w 232708"/>
+                <a:gd name="connsiteY0" fmla="*/ 0 h 457200"/>
+                <a:gd name="connsiteX1" fmla="*/ 232708 w 232708"/>
+                <a:gd name="connsiteY1" fmla="*/ 228600 h 457200"/>
+                <a:gd name="connsiteX2" fmla="*/ 4108 w 232708"/>
+                <a:gd name="connsiteY2" fmla="*/ 457200 h 457200"/>
+                <a:gd name="connsiteX3" fmla="*/ 0 w 232708"/>
+                <a:gd name="connsiteY3" fmla="*/ 456786 h 457200"/>
+                <a:gd name="connsiteX4" fmla="*/ 0 w 232708"/>
+                <a:gd name="connsiteY4" fmla="*/ 414 h 457200"/>
+                <a:gd name="connsiteX5" fmla="*/ 4108 w 232708"/>
+                <a:gd name="connsiteY5" fmla="*/ 0 h 457200"/>
+              </a:gdLst>
+              <a:ahLst/>
+              <a:cxnLst>
+                <a:cxn ang="0">
+                  <a:pos x="connsiteX0" y="connsiteY0"/>
+                </a:cxn>
+                <a:cxn ang="0">
+                  <a:pos x="connsiteX1" y="connsiteY1"/>
+                </a:cxn>
+                <a:cxn ang="0">
+                  <a:pos x="connsiteX2" y="connsiteY2"/>
+                </a:cxn>
+                <a:cxn ang="0">
+                  <a:pos x="connsiteX3" y="connsiteY3"/>
+                </a:cxn>
+                <a:cxn ang="0">
+                  <a:pos x="connsiteX4" y="connsiteY4"/>
+                </a:cxn>
+                <a:cxn ang="0">
+                  <a:pos x="connsiteX5" y="connsiteY5"/>
+                </a:cxn>
+              </a:cxnLst>
+              <a:rect l="l" t="t" r="r" b="b"/>
+              <a:pathLst>
+                <a:path w="232708" h="457200">
+                  <a:moveTo>
+                    <a:pt x="4108" y="0"/>
+                  </a:moveTo>
+                  <a:cubicBezTo>
+                    <a:pt x="130360" y="0"/>
+                    <a:pt x="232708" y="102348"/>
+                    <a:pt x="232708" y="228600"/>
+                  </a:cubicBezTo>
+                  <a:cubicBezTo>
+                    <a:pt x="232708" y="354852"/>
+                    <a:pt x="130360" y="457200"/>
+                    <a:pt x="4108" y="457200"/>
+                  </a:cubicBezTo>
+                  <a:lnTo>
+                    <a:pt x="0" y="456786"/>
+                  </a:lnTo>
+                  <a:lnTo>
+                    <a:pt x="0" y="414"/>
+                  </a:lnTo>
+                  <a:lnTo>
+                    <a:pt x="4108" y="0"/>
+                  </a:lnTo>
+                  <a:close/>
+                </a:path>
+              </a:pathLst>
+            </a:custGeom>
+            <a:solidFill>
+              <a:schemeClr val="accent1"/>
+            </a:solidFill>
+            <a:ln>
+              <a:solidFill>
+                <a:schemeClr val="bg1"/>
+              </a:solidFill>
+            </a:ln>
+          </p:spPr>
+          <p:style>
+            <a:lnRef idx="2">
+              <a:schemeClr val="accent1">
+                <a:shade val="15000"/>
+              </a:schemeClr>
+            </a:lnRef>
+            <a:fillRef idx="1">
+              <a:schemeClr val="accent1"/>
+            </a:fillRef>
+            <a:effectRef idx="0">
+              <a:schemeClr val="accent1"/>
+            </a:effectRef>
+            <a:fontRef idx="minor">
+              <a:schemeClr val="lt1"/>
+            </a:fontRef>
+          </p:style>
+          <p:txBody>
+            <a:bodyPr wrap="square" rtlCol="0" anchor="ctr">
+              <a:noAutofit/>
+            </a:bodyPr>
+            <a:lstStyle/>
+            <a:p>
+              <a:pPr algn="ctr"/>
+              <a:endParaRPr lang="en-US" dirty="0"/>
+            </a:p>
+          </p:txBody>
+        </p:sp>
+      </p:grpSp>
+    </p:spTree>
+    <p:extLst>
+      <p:ext uri="{BB962C8B-B14F-4D97-AF65-F5344CB8AC3E}">
+        <p14:creationId xmlns:p14="http://schemas.microsoft.com/office/powerpoint/2010/main" val="326321307"/>
+      </p:ext>
+    </p:extLst>
+  </p:cSld>
+  <p:clrMapOvr>
+    <a:masterClrMapping/>
+  </p:clrMapOvr>
+</p:sld>
+</file>
+
+<file path=ppt/slides/slide3.xml><?xml version="1.0" encoding="utf-8"?>
 <p:sld xmlns:a="http://schemas.openxmlformats.org/drawingml/2006/main" xmlns:r="http://schemas.openxmlformats.org/officeDocument/2006/relationships" xmlns:p="http://schemas.openxmlformats.org/presentationml/2006/main">
   <p:cSld>
     <p:spTree>

</xml_diff>

<commit_message>
Major edits and fixes
</commit_message>
<xml_diff>
--- a/lectures/from_propositional_logic_to_probability_theory/proportional_syllogism_on_steroids.pptx
+++ b/lectures/from_propositional_logic_to_probability_theory/proportional_syllogism_on_steroids.pptx
@@ -5,7 +5,7 @@
     <p:sldMasterId id="2147483708" r:id="rId1"/>
   </p:sldMasterIdLst>
   <p:notesMasterIdLst>
-    <p:notesMasterId r:id="rId8"/>
+    <p:notesMasterId r:id="rId9"/>
   </p:notesMasterIdLst>
   <p:sldIdLst>
     <p:sldId id="341" r:id="rId2"/>
@@ -14,6 +14,7 @@
     <p:sldId id="348" r:id="rId5"/>
     <p:sldId id="350" r:id="rId6"/>
     <p:sldId id="351" r:id="rId7"/>
+    <p:sldId id="352" r:id="rId8"/>
   </p:sldIdLst>
   <p:sldSz cx="9144000" cy="914400"/>
   <p:notesSz cx="6858000" cy="9144000"/>
@@ -6294,10 +6295,10 @@
       </p:sp>
       <p:sp>
         <p:nvSpPr>
-          <p:cNvPr id="9" name="Oval 8">
+          <p:cNvPr id="2" name="Oval 1">
             <a:extLst>
               <a:ext uri="{FF2B5EF4-FFF2-40B4-BE49-F238E27FC236}">
-                <a16:creationId xmlns:a16="http://schemas.microsoft.com/office/drawing/2014/main" id="{4E8A1D61-826F-D984-345F-60F1B9BBA3CE}"/>
+                <a16:creationId xmlns:a16="http://schemas.microsoft.com/office/drawing/2014/main" id="{AE99F2E1-DAAA-F63E-5A3A-D7AE592921CD}"/>
               </a:ext>
             </a:extLst>
           </p:cNvPr>
@@ -6308,14 +6309,14 @@
         </p:nvSpPr>
         <p:spPr>
           <a:xfrm>
-            <a:off x="7189258" y="229969"/>
+            <a:off x="1497541" y="228600"/>
             <a:ext cx="457200" cy="457200"/>
           </a:xfrm>
           <a:prstGeom prst="ellipse">
             <a:avLst/>
           </a:prstGeom>
           <a:solidFill>
-            <a:schemeClr val="accent1"/>
+            <a:schemeClr val="accent4"/>
           </a:solidFill>
           <a:ln>
             <a:solidFill>
@@ -6350,10 +6351,10 @@
       </p:sp>
       <p:sp>
         <p:nvSpPr>
-          <p:cNvPr id="2" name="Oval 1">
+          <p:cNvPr id="3" name="Oval 2">
             <a:extLst>
               <a:ext uri="{FF2B5EF4-FFF2-40B4-BE49-F238E27FC236}">
-                <a16:creationId xmlns:a16="http://schemas.microsoft.com/office/drawing/2014/main" id="{AE99F2E1-DAAA-F63E-5A3A-D7AE592921CD}"/>
+                <a16:creationId xmlns:a16="http://schemas.microsoft.com/office/drawing/2014/main" id="{29FC8C44-4630-3654-E59A-46F0E3BD55B2}"/>
               </a:ext>
             </a:extLst>
           </p:cNvPr>
@@ -6364,7 +6365,7 @@
         </p:nvSpPr>
         <p:spPr>
           <a:xfrm>
-            <a:off x="1497541" y="228600"/>
+            <a:off x="2129954" y="228600"/>
             <a:ext cx="457200" cy="457200"/>
           </a:xfrm>
           <a:prstGeom prst="ellipse">
@@ -6406,10 +6407,10 @@
       </p:sp>
       <p:sp>
         <p:nvSpPr>
-          <p:cNvPr id="3" name="Oval 2">
+          <p:cNvPr id="4" name="Oval 3">
             <a:extLst>
               <a:ext uri="{FF2B5EF4-FFF2-40B4-BE49-F238E27FC236}">
-                <a16:creationId xmlns:a16="http://schemas.microsoft.com/office/drawing/2014/main" id="{29FC8C44-4630-3654-E59A-46F0E3BD55B2}"/>
+                <a16:creationId xmlns:a16="http://schemas.microsoft.com/office/drawing/2014/main" id="{EF37E217-9081-6B09-F8BB-7985ACC5BC6E}"/>
               </a:ext>
             </a:extLst>
           </p:cNvPr>
@@ -6420,7 +6421,7 @@
         </p:nvSpPr>
         <p:spPr>
           <a:xfrm>
-            <a:off x="2129954" y="228600"/>
+            <a:off x="2762367" y="228600"/>
             <a:ext cx="457200" cy="457200"/>
           </a:xfrm>
           <a:prstGeom prst="ellipse">
@@ -6456,16 +6457,16 @@
           <a:lstStyle/>
           <a:p>
             <a:pPr algn="ctr"/>
-            <a:endParaRPr lang="en-US"/>
-          </a:p>
-        </p:txBody>
-      </p:sp>
-      <p:sp>
-        <p:nvSpPr>
-          <p:cNvPr id="4" name="Oval 3">
+            <a:endParaRPr lang="en-US" dirty="0"/>
+          </a:p>
+        </p:txBody>
+      </p:sp>
+      <p:sp>
+        <p:nvSpPr>
+          <p:cNvPr id="5" name="Oval 4">
             <a:extLst>
               <a:ext uri="{FF2B5EF4-FFF2-40B4-BE49-F238E27FC236}">
-                <a16:creationId xmlns:a16="http://schemas.microsoft.com/office/drawing/2014/main" id="{EF37E217-9081-6B09-F8BB-7985ACC5BC6E}"/>
+                <a16:creationId xmlns:a16="http://schemas.microsoft.com/office/drawing/2014/main" id="{682F8661-DAA4-8CA7-D8C5-0284829D501F}"/>
               </a:ext>
             </a:extLst>
           </p:cNvPr>
@@ -6476,14 +6477,14 @@
         </p:nvSpPr>
         <p:spPr>
           <a:xfrm>
-            <a:off x="2762367" y="228600"/>
+            <a:off x="4659606" y="228600"/>
             <a:ext cx="457200" cy="457200"/>
           </a:xfrm>
           <a:prstGeom prst="ellipse">
             <a:avLst/>
           </a:prstGeom>
           <a:solidFill>
-            <a:schemeClr val="accent4"/>
+            <a:schemeClr val="accent1"/>
           </a:solidFill>
           <a:ln>
             <a:solidFill>
@@ -6512,16 +6513,16 @@
           <a:lstStyle/>
           <a:p>
             <a:pPr algn="ctr"/>
-            <a:endParaRPr lang="en-US" dirty="0"/>
-          </a:p>
-        </p:txBody>
-      </p:sp>
-      <p:sp>
-        <p:nvSpPr>
-          <p:cNvPr id="5" name="Oval 4">
+            <a:endParaRPr lang="en-US"/>
+          </a:p>
+        </p:txBody>
+      </p:sp>
+      <p:sp>
+        <p:nvSpPr>
+          <p:cNvPr id="6" name="Oval 5">
             <a:extLst>
               <a:ext uri="{FF2B5EF4-FFF2-40B4-BE49-F238E27FC236}">
-                <a16:creationId xmlns:a16="http://schemas.microsoft.com/office/drawing/2014/main" id="{682F8661-DAA4-8CA7-D8C5-0284829D501F}"/>
+                <a16:creationId xmlns:a16="http://schemas.microsoft.com/office/drawing/2014/main" id="{BDF974F0-0A76-90E5-936D-EC6685A42F7C}"/>
               </a:ext>
             </a:extLst>
           </p:cNvPr>
@@ -6532,7 +6533,7 @@
         </p:nvSpPr>
         <p:spPr>
           <a:xfrm>
-            <a:off x="4659606" y="228600"/>
+            <a:off x="5292019" y="228600"/>
             <a:ext cx="457200" cy="457200"/>
           </a:xfrm>
           <a:prstGeom prst="ellipse">
@@ -6574,10 +6575,10 @@
       </p:sp>
       <p:sp>
         <p:nvSpPr>
-          <p:cNvPr id="6" name="Oval 5">
+          <p:cNvPr id="7" name="Oval 6">
             <a:extLst>
               <a:ext uri="{FF2B5EF4-FFF2-40B4-BE49-F238E27FC236}">
-                <a16:creationId xmlns:a16="http://schemas.microsoft.com/office/drawing/2014/main" id="{BDF974F0-0A76-90E5-936D-EC6685A42F7C}"/>
+                <a16:creationId xmlns:a16="http://schemas.microsoft.com/office/drawing/2014/main" id="{3EB687CB-D635-F093-E185-316AA823416E}"/>
               </a:ext>
             </a:extLst>
           </p:cNvPr>
@@ -6588,7 +6589,7 @@
         </p:nvSpPr>
         <p:spPr>
           <a:xfrm>
-            <a:off x="5292019" y="228600"/>
+            <a:off x="5924432" y="228600"/>
             <a:ext cx="457200" cy="457200"/>
           </a:xfrm>
           <a:prstGeom prst="ellipse">
@@ -6630,10 +6631,10 @@
       </p:sp>
       <p:sp>
         <p:nvSpPr>
-          <p:cNvPr id="7" name="Oval 6">
+          <p:cNvPr id="8" name="Oval 7">
             <a:extLst>
               <a:ext uri="{FF2B5EF4-FFF2-40B4-BE49-F238E27FC236}">
-                <a16:creationId xmlns:a16="http://schemas.microsoft.com/office/drawing/2014/main" id="{3EB687CB-D635-F093-E185-316AA823416E}"/>
+                <a16:creationId xmlns:a16="http://schemas.microsoft.com/office/drawing/2014/main" id="{8EF5889E-2F46-0276-89E2-E7FFA6302E4B}"/>
               </a:ext>
             </a:extLst>
           </p:cNvPr>
@@ -6644,7 +6645,7 @@
         </p:nvSpPr>
         <p:spPr>
           <a:xfrm>
-            <a:off x="5924432" y="228600"/>
+            <a:off x="6556845" y="228600"/>
             <a:ext cx="457200" cy="457200"/>
           </a:xfrm>
           <a:prstGeom prst="ellipse">
@@ -6686,10 +6687,10 @@
       </p:sp>
       <p:sp>
         <p:nvSpPr>
-          <p:cNvPr id="8" name="Oval 7">
+          <p:cNvPr id="11" name="Oval 10">
             <a:extLst>
               <a:ext uri="{FF2B5EF4-FFF2-40B4-BE49-F238E27FC236}">
-                <a16:creationId xmlns:a16="http://schemas.microsoft.com/office/drawing/2014/main" id="{8EF5889E-2F46-0276-89E2-E7FFA6302E4B}"/>
+                <a16:creationId xmlns:a16="http://schemas.microsoft.com/office/drawing/2014/main" id="{1CAF534E-2DD4-AF86-18CA-DB514213C572}"/>
               </a:ext>
             </a:extLst>
           </p:cNvPr>
@@ -6700,18 +6701,18 @@
         </p:nvSpPr>
         <p:spPr>
           <a:xfrm>
-            <a:off x="6556845" y="228600"/>
+            <a:off x="7189259" y="228600"/>
             <a:ext cx="457200" cy="457200"/>
           </a:xfrm>
           <a:prstGeom prst="ellipse">
             <a:avLst/>
           </a:prstGeom>
-          <a:solidFill>
-            <a:schemeClr val="accent1"/>
-          </a:solidFill>
+          <a:noFill/>
           <a:ln>
             <a:solidFill>
-              <a:schemeClr val="bg1"/>
+              <a:schemeClr val="bg2">
+                <a:lumMod val="90000"/>
+              </a:schemeClr>
             </a:solidFill>
           </a:ln>
         </p:spPr>
@@ -6744,6 +6745,602 @@
     <p:extLst>
       <p:ext uri="{BB962C8B-B14F-4D97-AF65-F5344CB8AC3E}">
         <p14:creationId xmlns:p14="http://schemas.microsoft.com/office/powerpoint/2010/main" val="3887831179"/>
+      </p:ext>
+    </p:extLst>
+  </p:cSld>
+  <p:clrMapOvr>
+    <a:masterClrMapping/>
+  </p:clrMapOvr>
+</p:sld>
+</file>
+
+<file path=ppt/slides/slide7.xml><?xml version="1.0" encoding="utf-8"?>
+<p:sld xmlns:a="http://schemas.openxmlformats.org/drawingml/2006/main" xmlns:r="http://schemas.openxmlformats.org/officeDocument/2006/relationships" xmlns:p="http://schemas.openxmlformats.org/presentationml/2006/main">
+  <p:cSld>
+    <p:spTree>
+      <p:nvGrpSpPr>
+        <p:cNvPr id="1" name="">
+          <a:extLst>
+            <a:ext uri="{FF2B5EF4-FFF2-40B4-BE49-F238E27FC236}">
+              <a16:creationId xmlns:a16="http://schemas.microsoft.com/office/drawing/2014/main" id="{0A46E06E-D6F6-5C27-5608-95C666B92DBD}"/>
+            </a:ext>
+          </a:extLst>
+        </p:cNvPr>
+        <p:cNvGrpSpPr/>
+        <p:nvPr/>
+      </p:nvGrpSpPr>
+      <p:grpSpPr>
+        <a:xfrm>
+          <a:off x="0" y="0"/>
+          <a:ext cx="0" cy="0"/>
+          <a:chOff x="0" y="0"/>
+          <a:chExt cx="0" cy="0"/>
+        </a:xfrm>
+      </p:grpSpPr>
+      <p:sp>
+        <p:nvSpPr>
+          <p:cNvPr id="14" name="Oval 13">
+            <a:extLst>
+              <a:ext uri="{FF2B5EF4-FFF2-40B4-BE49-F238E27FC236}">
+                <a16:creationId xmlns:a16="http://schemas.microsoft.com/office/drawing/2014/main" id="{52CB5852-35FC-20C4-F726-823EED5BA2C7}"/>
+              </a:ext>
+            </a:extLst>
+          </p:cNvPr>
+          <p:cNvSpPr>
+            <a:spLocks noChangeAspect="1"/>
+          </p:cNvSpPr>
+          <p:nvPr/>
+        </p:nvSpPr>
+        <p:spPr>
+          <a:xfrm>
+            <a:off x="4020843" y="228600"/>
+            <a:ext cx="457200" cy="457200"/>
+          </a:xfrm>
+          <a:prstGeom prst="ellipse">
+            <a:avLst/>
+          </a:prstGeom>
+          <a:solidFill>
+            <a:schemeClr val="accent1"/>
+          </a:solidFill>
+          <a:ln>
+            <a:solidFill>
+              <a:schemeClr val="bg1"/>
+            </a:solidFill>
+          </a:ln>
+        </p:spPr>
+        <p:style>
+          <a:lnRef idx="2">
+            <a:schemeClr val="accent1">
+              <a:shade val="15000"/>
+            </a:schemeClr>
+          </a:lnRef>
+          <a:fillRef idx="1">
+            <a:schemeClr val="accent1"/>
+          </a:fillRef>
+          <a:effectRef idx="0">
+            <a:schemeClr val="accent1"/>
+          </a:effectRef>
+          <a:fontRef idx="minor">
+            <a:schemeClr val="lt1"/>
+          </a:fontRef>
+        </p:style>
+        <p:txBody>
+          <a:bodyPr rtlCol="0" anchor="ctr"/>
+          <a:lstStyle/>
+          <a:p>
+            <a:pPr algn="ctr"/>
+            <a:endParaRPr lang="en-US"/>
+          </a:p>
+        </p:txBody>
+      </p:sp>
+      <p:sp>
+        <p:nvSpPr>
+          <p:cNvPr id="10" name="Oval 9">
+            <a:extLst>
+              <a:ext uri="{FF2B5EF4-FFF2-40B4-BE49-F238E27FC236}">
+                <a16:creationId xmlns:a16="http://schemas.microsoft.com/office/drawing/2014/main" id="{69F74B10-78EC-A66D-AE9C-60272977D869}"/>
+              </a:ext>
+            </a:extLst>
+          </p:cNvPr>
+          <p:cNvSpPr>
+            <a:spLocks noChangeAspect="1"/>
+          </p:cNvSpPr>
+          <p:nvPr/>
+        </p:nvSpPr>
+        <p:spPr>
+          <a:xfrm>
+            <a:off x="3401130" y="228600"/>
+            <a:ext cx="457200" cy="457200"/>
+          </a:xfrm>
+          <a:prstGeom prst="ellipse">
+            <a:avLst/>
+          </a:prstGeom>
+          <a:solidFill>
+            <a:schemeClr val="accent1"/>
+          </a:solidFill>
+          <a:ln>
+            <a:solidFill>
+              <a:schemeClr val="bg1"/>
+            </a:solidFill>
+          </a:ln>
+        </p:spPr>
+        <p:style>
+          <a:lnRef idx="2">
+            <a:schemeClr val="accent1">
+              <a:shade val="15000"/>
+            </a:schemeClr>
+          </a:lnRef>
+          <a:fillRef idx="1">
+            <a:schemeClr val="accent1"/>
+          </a:fillRef>
+          <a:effectRef idx="0">
+            <a:schemeClr val="accent1"/>
+          </a:effectRef>
+          <a:fontRef idx="minor">
+            <a:schemeClr val="lt1"/>
+          </a:fontRef>
+        </p:style>
+        <p:txBody>
+          <a:bodyPr rtlCol="0" anchor="ctr"/>
+          <a:lstStyle/>
+          <a:p>
+            <a:pPr algn="ctr"/>
+            <a:endParaRPr lang="en-US" dirty="0"/>
+          </a:p>
+        </p:txBody>
+      </p:sp>
+      <p:sp>
+        <p:nvSpPr>
+          <p:cNvPr id="9" name="Oval 8">
+            <a:extLst>
+              <a:ext uri="{FF2B5EF4-FFF2-40B4-BE49-F238E27FC236}">
+                <a16:creationId xmlns:a16="http://schemas.microsoft.com/office/drawing/2014/main" id="{910A3F45-B014-1546-4156-3DCB266AE32F}"/>
+              </a:ext>
+            </a:extLst>
+          </p:cNvPr>
+          <p:cNvSpPr>
+            <a:spLocks noChangeAspect="1"/>
+          </p:cNvSpPr>
+          <p:nvPr/>
+        </p:nvSpPr>
+        <p:spPr>
+          <a:xfrm>
+            <a:off x="7189258" y="229969"/>
+            <a:ext cx="457200" cy="457200"/>
+          </a:xfrm>
+          <a:prstGeom prst="ellipse">
+            <a:avLst/>
+          </a:prstGeom>
+          <a:solidFill>
+            <a:schemeClr val="accent1"/>
+          </a:solidFill>
+          <a:ln>
+            <a:solidFill>
+              <a:schemeClr val="bg1"/>
+            </a:solidFill>
+          </a:ln>
+        </p:spPr>
+        <p:style>
+          <a:lnRef idx="2">
+            <a:schemeClr val="accent1">
+              <a:shade val="15000"/>
+            </a:schemeClr>
+          </a:lnRef>
+          <a:fillRef idx="1">
+            <a:schemeClr val="accent1"/>
+          </a:fillRef>
+          <a:effectRef idx="0">
+            <a:schemeClr val="accent1"/>
+          </a:effectRef>
+          <a:fontRef idx="minor">
+            <a:schemeClr val="lt1"/>
+          </a:fontRef>
+        </p:style>
+        <p:txBody>
+          <a:bodyPr rtlCol="0" anchor="ctr"/>
+          <a:lstStyle/>
+          <a:p>
+            <a:pPr algn="ctr"/>
+            <a:endParaRPr lang="en-US"/>
+          </a:p>
+        </p:txBody>
+      </p:sp>
+      <p:sp>
+        <p:nvSpPr>
+          <p:cNvPr id="2" name="Oval 1">
+            <a:extLst>
+              <a:ext uri="{FF2B5EF4-FFF2-40B4-BE49-F238E27FC236}">
+                <a16:creationId xmlns:a16="http://schemas.microsoft.com/office/drawing/2014/main" id="{D7586966-4C39-E61C-C239-2BE412461625}"/>
+              </a:ext>
+            </a:extLst>
+          </p:cNvPr>
+          <p:cNvSpPr>
+            <a:spLocks noChangeAspect="1"/>
+          </p:cNvSpPr>
+          <p:nvPr/>
+        </p:nvSpPr>
+        <p:spPr>
+          <a:xfrm>
+            <a:off x="1497541" y="228600"/>
+            <a:ext cx="457200" cy="457200"/>
+          </a:xfrm>
+          <a:prstGeom prst="ellipse">
+            <a:avLst/>
+          </a:prstGeom>
+          <a:solidFill>
+            <a:schemeClr val="accent4"/>
+          </a:solidFill>
+          <a:ln>
+            <a:solidFill>
+              <a:schemeClr val="bg1"/>
+            </a:solidFill>
+          </a:ln>
+        </p:spPr>
+        <p:style>
+          <a:lnRef idx="2">
+            <a:schemeClr val="accent1">
+              <a:shade val="15000"/>
+            </a:schemeClr>
+          </a:lnRef>
+          <a:fillRef idx="1">
+            <a:schemeClr val="accent1"/>
+          </a:fillRef>
+          <a:effectRef idx="0">
+            <a:schemeClr val="accent1"/>
+          </a:effectRef>
+          <a:fontRef idx="minor">
+            <a:schemeClr val="lt1"/>
+          </a:fontRef>
+        </p:style>
+        <p:txBody>
+          <a:bodyPr rtlCol="0" anchor="ctr"/>
+          <a:lstStyle/>
+          <a:p>
+            <a:pPr algn="ctr"/>
+            <a:endParaRPr lang="en-US"/>
+          </a:p>
+        </p:txBody>
+      </p:sp>
+      <p:sp>
+        <p:nvSpPr>
+          <p:cNvPr id="3" name="Oval 2">
+            <a:extLst>
+              <a:ext uri="{FF2B5EF4-FFF2-40B4-BE49-F238E27FC236}">
+                <a16:creationId xmlns:a16="http://schemas.microsoft.com/office/drawing/2014/main" id="{C446A577-E563-6CE6-247F-77BE6A0CB5BB}"/>
+              </a:ext>
+            </a:extLst>
+          </p:cNvPr>
+          <p:cNvSpPr>
+            <a:spLocks noChangeAspect="1"/>
+          </p:cNvSpPr>
+          <p:nvPr/>
+        </p:nvSpPr>
+        <p:spPr>
+          <a:xfrm>
+            <a:off x="2129954" y="228600"/>
+            <a:ext cx="457200" cy="457200"/>
+          </a:xfrm>
+          <a:prstGeom prst="ellipse">
+            <a:avLst/>
+          </a:prstGeom>
+          <a:solidFill>
+            <a:schemeClr val="accent4"/>
+          </a:solidFill>
+          <a:ln>
+            <a:solidFill>
+              <a:schemeClr val="bg1"/>
+            </a:solidFill>
+          </a:ln>
+        </p:spPr>
+        <p:style>
+          <a:lnRef idx="2">
+            <a:schemeClr val="accent1">
+              <a:shade val="15000"/>
+            </a:schemeClr>
+          </a:lnRef>
+          <a:fillRef idx="1">
+            <a:schemeClr val="accent1"/>
+          </a:fillRef>
+          <a:effectRef idx="0">
+            <a:schemeClr val="accent1"/>
+          </a:effectRef>
+          <a:fontRef idx="minor">
+            <a:schemeClr val="lt1"/>
+          </a:fontRef>
+        </p:style>
+        <p:txBody>
+          <a:bodyPr rtlCol="0" anchor="ctr"/>
+          <a:lstStyle/>
+          <a:p>
+            <a:pPr algn="ctr"/>
+            <a:endParaRPr lang="en-US"/>
+          </a:p>
+        </p:txBody>
+      </p:sp>
+      <p:sp>
+        <p:nvSpPr>
+          <p:cNvPr id="4" name="Oval 3">
+            <a:extLst>
+              <a:ext uri="{FF2B5EF4-FFF2-40B4-BE49-F238E27FC236}">
+                <a16:creationId xmlns:a16="http://schemas.microsoft.com/office/drawing/2014/main" id="{2BD50B31-9C42-646C-5186-6E9A97EB28E8}"/>
+              </a:ext>
+            </a:extLst>
+          </p:cNvPr>
+          <p:cNvSpPr>
+            <a:spLocks noChangeAspect="1"/>
+          </p:cNvSpPr>
+          <p:nvPr/>
+        </p:nvSpPr>
+        <p:spPr>
+          <a:xfrm>
+            <a:off x="2762367" y="228600"/>
+            <a:ext cx="457200" cy="457200"/>
+          </a:xfrm>
+          <a:prstGeom prst="ellipse">
+            <a:avLst/>
+          </a:prstGeom>
+          <a:solidFill>
+            <a:schemeClr val="accent4"/>
+          </a:solidFill>
+          <a:ln>
+            <a:solidFill>
+              <a:schemeClr val="bg1"/>
+            </a:solidFill>
+          </a:ln>
+        </p:spPr>
+        <p:style>
+          <a:lnRef idx="2">
+            <a:schemeClr val="accent1">
+              <a:shade val="15000"/>
+            </a:schemeClr>
+          </a:lnRef>
+          <a:fillRef idx="1">
+            <a:schemeClr val="accent1"/>
+          </a:fillRef>
+          <a:effectRef idx="0">
+            <a:schemeClr val="accent1"/>
+          </a:effectRef>
+          <a:fontRef idx="minor">
+            <a:schemeClr val="lt1"/>
+          </a:fontRef>
+        </p:style>
+        <p:txBody>
+          <a:bodyPr rtlCol="0" anchor="ctr"/>
+          <a:lstStyle/>
+          <a:p>
+            <a:pPr algn="ctr"/>
+            <a:endParaRPr lang="en-US" dirty="0"/>
+          </a:p>
+        </p:txBody>
+      </p:sp>
+      <p:sp>
+        <p:nvSpPr>
+          <p:cNvPr id="5" name="Oval 4">
+            <a:extLst>
+              <a:ext uri="{FF2B5EF4-FFF2-40B4-BE49-F238E27FC236}">
+                <a16:creationId xmlns:a16="http://schemas.microsoft.com/office/drawing/2014/main" id="{A141567D-7CFB-4DA0-5872-7745B17A64FA}"/>
+              </a:ext>
+            </a:extLst>
+          </p:cNvPr>
+          <p:cNvSpPr>
+            <a:spLocks noChangeAspect="1"/>
+          </p:cNvSpPr>
+          <p:nvPr/>
+        </p:nvSpPr>
+        <p:spPr>
+          <a:xfrm>
+            <a:off x="4659606" y="228600"/>
+            <a:ext cx="457200" cy="457200"/>
+          </a:xfrm>
+          <a:prstGeom prst="ellipse">
+            <a:avLst/>
+          </a:prstGeom>
+          <a:solidFill>
+            <a:schemeClr val="accent1"/>
+          </a:solidFill>
+          <a:ln>
+            <a:solidFill>
+              <a:schemeClr val="bg1"/>
+            </a:solidFill>
+          </a:ln>
+        </p:spPr>
+        <p:style>
+          <a:lnRef idx="2">
+            <a:schemeClr val="accent1">
+              <a:shade val="15000"/>
+            </a:schemeClr>
+          </a:lnRef>
+          <a:fillRef idx="1">
+            <a:schemeClr val="accent1"/>
+          </a:fillRef>
+          <a:effectRef idx="0">
+            <a:schemeClr val="accent1"/>
+          </a:effectRef>
+          <a:fontRef idx="minor">
+            <a:schemeClr val="lt1"/>
+          </a:fontRef>
+        </p:style>
+        <p:txBody>
+          <a:bodyPr rtlCol="0" anchor="ctr"/>
+          <a:lstStyle/>
+          <a:p>
+            <a:pPr algn="ctr"/>
+            <a:endParaRPr lang="en-US"/>
+          </a:p>
+        </p:txBody>
+      </p:sp>
+      <p:sp>
+        <p:nvSpPr>
+          <p:cNvPr id="6" name="Oval 5">
+            <a:extLst>
+              <a:ext uri="{FF2B5EF4-FFF2-40B4-BE49-F238E27FC236}">
+                <a16:creationId xmlns:a16="http://schemas.microsoft.com/office/drawing/2014/main" id="{CC2EAFF2-238D-CA44-FB51-A151D0A8A635}"/>
+              </a:ext>
+            </a:extLst>
+          </p:cNvPr>
+          <p:cNvSpPr>
+            <a:spLocks noChangeAspect="1"/>
+          </p:cNvSpPr>
+          <p:nvPr/>
+        </p:nvSpPr>
+        <p:spPr>
+          <a:xfrm>
+            <a:off x="5292019" y="228600"/>
+            <a:ext cx="457200" cy="457200"/>
+          </a:xfrm>
+          <a:prstGeom prst="ellipse">
+            <a:avLst/>
+          </a:prstGeom>
+          <a:solidFill>
+            <a:schemeClr val="accent1"/>
+          </a:solidFill>
+          <a:ln>
+            <a:solidFill>
+              <a:schemeClr val="bg1"/>
+            </a:solidFill>
+          </a:ln>
+        </p:spPr>
+        <p:style>
+          <a:lnRef idx="2">
+            <a:schemeClr val="accent1">
+              <a:shade val="15000"/>
+            </a:schemeClr>
+          </a:lnRef>
+          <a:fillRef idx="1">
+            <a:schemeClr val="accent1"/>
+          </a:fillRef>
+          <a:effectRef idx="0">
+            <a:schemeClr val="accent1"/>
+          </a:effectRef>
+          <a:fontRef idx="minor">
+            <a:schemeClr val="lt1"/>
+          </a:fontRef>
+        </p:style>
+        <p:txBody>
+          <a:bodyPr rtlCol="0" anchor="ctr"/>
+          <a:lstStyle/>
+          <a:p>
+            <a:pPr algn="ctr"/>
+            <a:endParaRPr lang="en-US"/>
+          </a:p>
+        </p:txBody>
+      </p:sp>
+      <p:sp>
+        <p:nvSpPr>
+          <p:cNvPr id="7" name="Oval 6">
+            <a:extLst>
+              <a:ext uri="{FF2B5EF4-FFF2-40B4-BE49-F238E27FC236}">
+                <a16:creationId xmlns:a16="http://schemas.microsoft.com/office/drawing/2014/main" id="{B18FD4A6-FE42-F0ED-6E77-373AC3F6297D}"/>
+              </a:ext>
+            </a:extLst>
+          </p:cNvPr>
+          <p:cNvSpPr>
+            <a:spLocks noChangeAspect="1"/>
+          </p:cNvSpPr>
+          <p:nvPr/>
+        </p:nvSpPr>
+        <p:spPr>
+          <a:xfrm>
+            <a:off x="5924432" y="228600"/>
+            <a:ext cx="457200" cy="457200"/>
+          </a:xfrm>
+          <a:prstGeom prst="ellipse">
+            <a:avLst/>
+          </a:prstGeom>
+          <a:solidFill>
+            <a:schemeClr val="accent1"/>
+          </a:solidFill>
+          <a:ln>
+            <a:solidFill>
+              <a:schemeClr val="bg1"/>
+            </a:solidFill>
+          </a:ln>
+        </p:spPr>
+        <p:style>
+          <a:lnRef idx="2">
+            <a:schemeClr val="accent1">
+              <a:shade val="15000"/>
+            </a:schemeClr>
+          </a:lnRef>
+          <a:fillRef idx="1">
+            <a:schemeClr val="accent1"/>
+          </a:fillRef>
+          <a:effectRef idx="0">
+            <a:schemeClr val="accent1"/>
+          </a:effectRef>
+          <a:fontRef idx="minor">
+            <a:schemeClr val="lt1"/>
+          </a:fontRef>
+        </p:style>
+        <p:txBody>
+          <a:bodyPr rtlCol="0" anchor="ctr"/>
+          <a:lstStyle/>
+          <a:p>
+            <a:pPr algn="ctr"/>
+            <a:endParaRPr lang="en-US"/>
+          </a:p>
+        </p:txBody>
+      </p:sp>
+      <p:sp>
+        <p:nvSpPr>
+          <p:cNvPr id="8" name="Oval 7">
+            <a:extLst>
+              <a:ext uri="{FF2B5EF4-FFF2-40B4-BE49-F238E27FC236}">
+                <a16:creationId xmlns:a16="http://schemas.microsoft.com/office/drawing/2014/main" id="{9778A5BF-7EA8-E792-B738-D2AEE9C93F08}"/>
+              </a:ext>
+            </a:extLst>
+          </p:cNvPr>
+          <p:cNvSpPr>
+            <a:spLocks noChangeAspect="1"/>
+          </p:cNvSpPr>
+          <p:nvPr/>
+        </p:nvSpPr>
+        <p:spPr>
+          <a:xfrm>
+            <a:off x="6556845" y="228600"/>
+            <a:ext cx="457200" cy="457200"/>
+          </a:xfrm>
+          <a:prstGeom prst="ellipse">
+            <a:avLst/>
+          </a:prstGeom>
+          <a:solidFill>
+            <a:schemeClr val="accent1"/>
+          </a:solidFill>
+          <a:ln>
+            <a:solidFill>
+              <a:schemeClr val="bg1"/>
+            </a:solidFill>
+          </a:ln>
+        </p:spPr>
+        <p:style>
+          <a:lnRef idx="2">
+            <a:schemeClr val="accent1">
+              <a:shade val="15000"/>
+            </a:schemeClr>
+          </a:lnRef>
+          <a:fillRef idx="1">
+            <a:schemeClr val="accent1"/>
+          </a:fillRef>
+          <a:effectRef idx="0">
+            <a:schemeClr val="accent1"/>
+          </a:effectRef>
+          <a:fontRef idx="minor">
+            <a:schemeClr val="lt1"/>
+          </a:fontRef>
+        </p:style>
+        <p:txBody>
+          <a:bodyPr rtlCol="0" anchor="ctr"/>
+          <a:lstStyle/>
+          <a:p>
+            <a:pPr algn="ctr"/>
+            <a:endParaRPr lang="en-US"/>
+          </a:p>
+        </p:txBody>
+      </p:sp>
+    </p:spTree>
+    <p:extLst>
+      <p:ext uri="{BB962C8B-B14F-4D97-AF65-F5344CB8AC3E}">
+        <p14:creationId xmlns:p14="http://schemas.microsoft.com/office/powerpoint/2010/main" val="1729984583"/>
       </p:ext>
     </p:extLst>
   </p:cSld>

</xml_diff>